<commit_message>
Nettoyage editorial du rendu (emojis, typographie)
</commit_message>
<xml_diff>
--- a/rendu/03_FraudAI_Presentation.pptx
+++ b/rendu/03_FraudAI_Presentation.pptx
@@ -3260,7 +3260,7 @@
                 </a:solidFill>
                 <a:latin typeface="Calibri"/>
               </a:rPr>
-              <a:t>L'IA aide l'agent — la décision finale reste humaine.</a:t>
+              <a:t>L'IA aide l'agent - la décision finale reste humaine.</a:t>
             </a:r>
           </a:p>
         </p:txBody>
@@ -3305,7 +3305,7 @@
                 </a:solidFill>
                 <a:latin typeface="Calibri"/>
               </a:rPr>
-              <a:t>Projet Fil Rouge — MSc Machine Learning, EPITA 2026</a:t>
+              <a:t>Projet Fil Rouge - MSc Machine Learning, EPITA 2026</a:t>
             </a:r>
           </a:p>
         </p:txBody>
@@ -3490,7 +3490,7 @@
                 </a:solidFill>
                 <a:latin typeface="Calibri"/>
               </a:rPr>
-              <a:t>FraudAI — Détection de fraude CPAM · MSc Machine Learning EPITA 2026</a:t>
+              <a:t>FraudAI - Détection de fraude CPAM · MSc Machine Learning EPITA 2026</a:t>
             </a:r>
           </a:p>
         </p:txBody>
@@ -3778,7 +3778,7 @@
                 </a:solidFill>
                 <a:latin typeface="Calibri"/>
               </a:rPr>
-              <a:t>FraudAI — Détection de fraude CPAM · MSc Machine Learning EPITA 2026</a:t>
+              <a:t>FraudAI - Détection de fraude CPAM · MSc Machine Learning EPITA 2026</a:t>
             </a:r>
           </a:p>
         </p:txBody>
@@ -3833,7 +3833,7 @@
                 </a:solidFill>
                 <a:latin typeface="Calibri"/>
               </a:rPr>
-              <a:t>•  Le backend charge le même fraudai_model.pkl que le notebook → scores identiques.</a:t>
+              <a:t>•  Le backend charge le même fraudai_model.pkl que le notebook -&gt; scores identiques.</a:t>
             </a:r>
           </a:p>
           <a:p>
@@ -3865,7 +3865,7 @@
                 </a:solidFill>
                 <a:latin typeface="Calibri"/>
               </a:rPr>
-              <a:t>•  Recommandation au comité : pilote CPAM régional, 700 k€ / 8 mois, sous 3 conditions —</a:t>
+              <a:t>•  Recommandation au comité : pilote CPAM régional, 700 k€ / 8 mois, sous 3 conditions -</a:t>
             </a:r>
           </a:p>
           <a:p>
@@ -3881,7 +3881,7 @@
                 </a:solidFill>
                 <a:latin typeface="Calibri"/>
               </a:rPr>
-              <a:t>–  réentraînement sur données réelles · audit de biais indépendant · supervision humaine garantie.</a:t>
+              <a:t>-  réentraînement sur données réelles · audit de biais indépendant · supervision humaine garantie.</a:t>
             </a:r>
           </a:p>
         </p:txBody>
@@ -4119,7 +4119,7 @@
                 </a:solidFill>
                 <a:latin typeface="Calibri"/>
               </a:rPr>
-              <a:t>FraudAI — Détection de fraude CPAM · MSc Machine Learning EPITA 2026</a:t>
+              <a:t>FraudAI - Détection de fraude CPAM · MSc Machine Learning EPITA 2026</a:t>
             </a:r>
           </a:p>
         </p:txBody>
@@ -4407,7 +4407,7 @@
                 </a:solidFill>
                 <a:latin typeface="Calibri"/>
               </a:rPr>
-              <a:t>FraudAI — Détection de fraude CPAM · MSc Machine Learning EPITA 2026</a:t>
+              <a:t>FraudAI - Détection de fraude CPAM · MSc Machine Learning EPITA 2026</a:t>
             </a:r>
           </a:p>
         </p:txBody>
@@ -4478,7 +4478,7 @@
                 </a:solidFill>
                 <a:latin typeface="Calibri"/>
               </a:rPr>
-              <a:t>–  Amount → montant remboursé</a:t>
+              <a:t>-  Amount -&gt; montant remboursé</a:t>
             </a:r>
           </a:p>
           <a:p>
@@ -4494,7 +4494,7 @@
                 </a:solidFill>
                 <a:latin typeface="Calibri"/>
               </a:rPr>
-              <a:t>–  V1–V28 (ACP) → profil anonymisé (secret médical / RGPD)</a:t>
+              <a:t>-  V1-V28 (ACP) -&gt; profil anonymisé (secret médical / RGPD)</a:t>
             </a:r>
           </a:p>
           <a:p>
@@ -4510,7 +4510,7 @@
                 </a:solidFill>
                 <a:latin typeface="Calibri"/>
               </a:rPr>
-              <a:t>–  Class → fraude avérée après contrôle d'un agent</a:t>
+              <a:t>-  Class -&gt; fraude avérée après contrôle d'un agent</a:t>
             </a:r>
           </a:p>
           <a:p>
@@ -4526,7 +4526,7 @@
                 </a:solidFill>
                 <a:latin typeface="Calibri"/>
               </a:rPr>
-              <a:t>•  Problème métier : prioriser automatiquement les dossiers à risque, augmenter la détection, réduire les contrôles inutiles — sans déléguer la décision.</a:t>
+              <a:t>•  Problème métier : prioriser automatiquement les dossiers à risque, augmenter la détection, réduire les contrôles inutiles - sans déléguer la décision.</a:t>
             </a:r>
           </a:p>
         </p:txBody>
@@ -4711,7 +4711,7 @@
                 </a:solidFill>
                 <a:latin typeface="Calibri"/>
               </a:rPr>
-              <a:t>FraudAI — Détection de fraude CPAM · MSc Machine Learning EPITA 2026</a:t>
+              <a:t>FraudAI - Détection de fraude CPAM · MSc Machine Learning EPITA 2026</a:t>
             </a:r>
           </a:p>
         </p:txBody>
@@ -5227,7 +5227,7 @@
                 </a:solidFill>
                 <a:latin typeface="Calibri"/>
               </a:rPr>
-              <a:t>FraudAI — Détection de fraude CPAM · MSc Machine Learning EPITA 2026</a:t>
+              <a:t>FraudAI - Détection de fraude CPAM · MSc Machine Learning EPITA 2026</a:t>
             </a:r>
           </a:p>
         </p:txBody>
@@ -5266,7 +5266,7 @@
                 </a:solidFill>
                 <a:latin typeface="Calibri"/>
               </a:rPr>
-              <a:t>•  284 807 → 283 726 transactions après retrait de 1 081 doublons (anti-fuite train/test).</a:t>
+              <a:t>•  284 807 -&gt; 283 726 transactions après retrait de 1 081 doublons (anti-fuite train/test).</a:t>
             </a:r>
           </a:p>
           <a:p>
@@ -5282,7 +5282,7 @@
                 </a:solidFill>
                 <a:latin typeface="Calibri"/>
               </a:rPr>
-              <a:t>•  Déséquilibre extrême : 1 fraude pour ~600 → métriques adaptées (AUC-PR, Recall), pas l'accuracy.</a:t>
+              <a:t>•  Déséquilibre extrême : 1 fraude pour ~600 -&gt; métriques adaptées (AUC-PR, Recall), pas l'accuracy.</a:t>
             </a:r>
           </a:p>
           <a:p>
@@ -5421,7 +5421,7 @@
                 </a:solidFill>
                 <a:latin typeface="Calibri"/>
               </a:rPr>
-              <a:t>Méthodologie rigoureuse — anti-fuite</a:t>
+              <a:t>Méthodologie rigoureuse - anti-fuite</a:t>
             </a:r>
           </a:p>
         </p:txBody>
@@ -5499,7 +5499,7 @@
                 </a:solidFill>
                 <a:latin typeface="Calibri"/>
               </a:rPr>
-              <a:t>FraudAI — Détection de fraude CPAM · MSc Machine Learning EPITA 2026</a:t>
+              <a:t>FraudAI - Détection de fraude CPAM · MSc Machine Learning EPITA 2026</a:t>
             </a:r>
           </a:p>
         </p:txBody>
@@ -5602,7 +5602,7 @@
                 </a:solidFill>
                 <a:latin typeface="Calibri"/>
               </a:rPr>
-              <a:t>•  Pipeline rendu déterministe (n_jobs=1) → chiffres parfaitement reproductibles.</a:t>
+              <a:t>•  Pipeline rendu déterministe (n_jobs=1) -&gt; chiffres parfaitement reproductibles.</a:t>
             </a:r>
           </a:p>
         </p:txBody>
@@ -5787,7 +5787,7 @@
                 </a:solidFill>
                 <a:latin typeface="Calibri"/>
               </a:rPr>
-              <a:t>FraudAI — Détection de fraude CPAM · MSc Machine Learning EPITA 2026</a:t>
+              <a:t>FraudAI - Détection de fraude CPAM · MSc Machine Learning EPITA 2026</a:t>
             </a:r>
           </a:p>
         </p:txBody>
@@ -5826,7 +5826,7 @@
                 </a:solidFill>
                 <a:latin typeface="Calibri"/>
               </a:rPr>
-              <a:t>•  Piège 1 — double-correction : SMOTE + class_weight → seuil pathologique (~1,0). Comparé et écarté.</a:t>
+              <a:t>•  Piège 1 - double-correction : SMOTE + class_weight -&gt; seuil pathologique (~1,0). Comparé et écarté.</a:t>
             </a:r>
           </a:p>
           <a:p>
@@ -5842,7 +5842,7 @@
                 </a:solidFill>
                 <a:latin typeface="Calibri"/>
               </a:rPr>
-              <a:t>•  Piège 2 — fuite de seuil : régler le seuil sur le test donnait un « 80 % » à 97 % de précision… illusoire.</a:t>
+              <a:t>•  Piège 2 - fuite de seuil : régler le seuil sur le test donnait un « 80 % » à 97 % de précision… illusoire.</a:t>
             </a:r>
           </a:p>
           <a:p>
@@ -5858,7 +5858,7 @@
                 </a:solidFill>
                 <a:latin typeface="Calibri"/>
               </a:rPr>
-              <a:t>•  Corrigé via le jeu de validation → résultat HONNÊTE :</a:t>
+              <a:t>•  Corrigé via le jeu de validation -&gt; résultat HONNÊTE :</a:t>
             </a:r>
           </a:p>
           <a:p>
@@ -5874,7 +5874,7 @@
                 </a:solidFill>
                 <a:latin typeface="Calibri"/>
               </a:rPr>
-              <a:t>–  Recall 80,0 % au prix d'une précision de 83,5 % (15 FP sur 56 746 transactions de test).</a:t>
+              <a:t>-  Recall 80,0 % au prix d'une précision de 83,5 % (15 FP sur 56 746 transactions de test).</a:t>
             </a:r>
           </a:p>
           <a:p>
@@ -6075,7 +6075,7 @@
                 </a:solidFill>
                 <a:latin typeface="Calibri"/>
               </a:rPr>
-              <a:t>FraudAI — Détection de fraude CPAM · MSc Machine Learning EPITA 2026</a:t>
+              <a:t>FraudAI - Détection de fraude CPAM · MSc Machine Learning EPITA 2026</a:t>
             </a:r>
           </a:p>
         </p:txBody>
@@ -6445,7 +6445,7 @@
                 </a:solidFill>
                 <a:latin typeface="Calibri"/>
               </a:rPr>
-              <a:t>–  F1-optimal : Recall 72,6 % · Précision 94,5 % · 4 FP</a:t>
+              <a:t>-  F1-optimal : Recall 72,6 % · Précision 94,5 % · 4 FP</a:t>
             </a:r>
           </a:p>
           <a:p>
@@ -6461,7 +6461,7 @@
                 </a:solidFill>
                 <a:latin typeface="Calibri"/>
               </a:rPr>
-              <a:t>–  Déploiement : Recall 80,0 % · Précision 83,5 % · 15 FP</a:t>
+              <a:t>-  Déploiement : Recall 80,0 % · Précision 83,5 % · 15 FP</a:t>
             </a:r>
           </a:p>
           <a:p>
@@ -6662,7 +6662,7 @@
                 </a:solidFill>
                 <a:latin typeface="Calibri"/>
               </a:rPr>
-              <a:t>FraudAI — Détection de fraude CPAM · MSc Machine Learning EPITA 2026</a:t>
+              <a:t>FraudAI - Détection de fraude CPAM · MSc Machine Learning EPITA 2026</a:t>
             </a:r>
           </a:p>
         </p:txBody>
@@ -6717,7 +6717,7 @@
                 </a:solidFill>
                 <a:latin typeface="Calibri"/>
               </a:rPr>
-              <a:t>–  Ex. dossier signalé (score 92/100) → facteurs V14, V10, V12 affichés à l'agent.</a:t>
+              <a:t>-  Ex. dossier signalé (score 92/100) -&gt; facteurs V14, V10, V12 affichés à l'agent.</a:t>
             </a:r>
           </a:p>
           <a:p>
@@ -6733,7 +6733,7 @@
                 </a:solidFill>
                 <a:latin typeface="Calibri"/>
               </a:rPr>
-              <a:t>•  L'agent voit POURQUOI un dossier est à risque → décision humaine éclairée + réponse au citoyen.</a:t>
+              <a:t>•  L'agent voit POURQUOI un dossier est à risque -&gt; décision humaine éclairée + réponse au citoyen.</a:t>
             </a:r>
           </a:p>
           <a:p>
@@ -6765,7 +6765,7 @@
                 </a:solidFill>
                 <a:latin typeface="Calibri"/>
               </a:rPr>
-              <a:t>–  Mesures correctives : audit d'équité par décile, SHAP obligatoire, réévaluation sur données récentes.</a:t>
+              <a:t>-  Mesures correctives : audit d'équité par décile, SHAP obligatoire, réévaluation sur données récentes.</a:t>
             </a:r>
           </a:p>
         </p:txBody>

</xml_diff>